<commit_message>
Refine pitch deck product flow
</commit_message>
<xml_diff>
--- a/outputs/ContentSeal_Pitch_Deck.pptx
+++ b/outputs/ContentSeal_Pitch_Deck.pptx
@@ -10458,7 +10458,7 @@
                   <a:srgbClr val="EEF8F2"/>
                 </a:solidFill>
               </a:rPr>
-              <a:t>A product flow judges can follow</a:t>
+              <a:t>Show the product flow</a:t>
             </a:r>
           </a:p>
         </p:txBody>
@@ -10508,7 +10508,7 @@
                   <a:srgbClr val="A6B8AF"/>
                 </a:solidFill>
               </a:rPr>
-              <a:t>The demo follows the exact source-recovery loop.</a:t>
+              <a:t>Seal source -&gt; recover screenshot -&gt; open proof -&gt; warn limits.</a:t>
             </a:r>
           </a:p>
         </p:txBody>
@@ -14050,7 +14050,7 @@
                   <a:srgbClr val="EEF8F2"/>
                 </a:solidFill>
               </a:rPr>
-              <a:t>Live Vercel demo with Firebase-backed persistence.</a:t>
+              <a:t>Live Vercel prototype with Firebase-backed persistence.</a:t>
             </a:r>
           </a:p>
         </p:txBody>
@@ -14212,7 +14212,7 @@
                   <a:srgbClr val="EEF8F2"/>
                 </a:solidFill>
               </a:rPr>
-              <a:t>Demo fixtures cover original, screenshot/repost, edited copy, and unknown image.</a:t>
+              <a:t>Fixture checks cover original, screenshot/repost, edited copy, and unknown image.</a:t>
             </a:r>
           </a:p>
         </p:txBody>
@@ -14430,7 +14430,7 @@
                   <a:srgbClr val="EEF8F2"/>
                 </a:solidFill>
               </a:rPr>
-              <a:t>works in demo</a:t>
+              <a:t>works live</a:t>
             </a:r>
           </a:p>
           <a:p xmlns:a="http://schemas.openxmlformats.org/drawingml/2006/main">
@@ -15652,7 +15652,7 @@
                   <a:srgbClr val="A3FF7A"/>
                 </a:solidFill>
               </a:rPr>
-              <a:t>LIVE DEMO</a:t>
+              <a:t>LIVE SITE</a:t>
             </a:r>
           </a:p>
         </p:txBody>

</xml_diff>